<commit_message>
Refine slide wording and localize Markdown notes
</commit_message>
<xml_diff>
--- a/01_Slides/presentation.pptx
+++ b/01_Slides/presentation.pptx
@@ -2,18 +2,18 @@
 <file path=ppt/presentation.xml><?xml version="1.0" encoding="utf-8"?>
 <p:presentation xmlns:p="http://schemas.openxmlformats.org/presentationml/2006/main">
   <p:sldMasterIdLst>
-    <p:sldMasterId xmlns:r="http://schemas.openxmlformats.org/officeDocument/2006/relationships" id="2147483648" r:id="R20b7c30dd00c4ab8"/>
+    <p:sldMasterId xmlns:r="http://schemas.openxmlformats.org/officeDocument/2006/relationships" id="2147483648" r:id="R7df315f7f3ed4263"/>
   </p:sldMasterIdLst>
   <p:notesMasterIdLst>
-    <p:notesMasterId xmlns:r="http://schemas.openxmlformats.org/officeDocument/2006/relationships" r:id="Rfdf67e5aefb14087"/>
+    <p:notesMasterId xmlns:r="http://schemas.openxmlformats.org/officeDocument/2006/relationships" r:id="Rf1be43994fd843bf"/>
   </p:notesMasterIdLst>
   <p:sldIdLst>
-    <p:sldId xmlns:r="http://schemas.openxmlformats.org/officeDocument/2006/relationships" id="256" r:id="Rc3375728ee8d4812"/>
-    <p:sldId xmlns:r="http://schemas.openxmlformats.org/officeDocument/2006/relationships" id="257" r:id="R9d7ee19723fd4fd3"/>
-    <p:sldId xmlns:r="http://schemas.openxmlformats.org/officeDocument/2006/relationships" id="258" r:id="Ra653024e92774a4b"/>
-    <p:sldId xmlns:r="http://schemas.openxmlformats.org/officeDocument/2006/relationships" id="259" r:id="Raf9348a36ce94f11"/>
-    <p:sldId xmlns:r="http://schemas.openxmlformats.org/officeDocument/2006/relationships" id="260" r:id="Rc2ac6318d9da48ce"/>
-    <p:sldId xmlns:r="http://schemas.openxmlformats.org/officeDocument/2006/relationships" id="261" r:id="Re710b5205a9b4ca4"/>
+    <p:sldId xmlns:r="http://schemas.openxmlformats.org/officeDocument/2006/relationships" id="256" r:id="R6f71f8b6cf264b5e"/>
+    <p:sldId xmlns:r="http://schemas.openxmlformats.org/officeDocument/2006/relationships" id="257" r:id="R746a0daf22804396"/>
+    <p:sldId xmlns:r="http://schemas.openxmlformats.org/officeDocument/2006/relationships" id="258" r:id="Rcc4c722d3bd44275"/>
+    <p:sldId xmlns:r="http://schemas.openxmlformats.org/officeDocument/2006/relationships" id="259" r:id="R59c48aaf922741b8"/>
+    <p:sldId xmlns:r="http://schemas.openxmlformats.org/officeDocument/2006/relationships" id="260" r:id="Ra7a981b38746448d"/>
+    <p:sldId xmlns:r="http://schemas.openxmlformats.org/officeDocument/2006/relationships" id="261" r:id="Rbca81cc30ba14e35"/>
   </p:sldIdLst>
   <p:sldSz cx="12192000" cy="6858000"/>
   <p:notesSz cx="6858000" cy="9144000"/>
@@ -936,7 +936,7 @@
   </p:cSld>
   <p:clrMap bg1="lt1" tx1="dk1" bg2="lt2" tx2="dk2" accent1="accent1" accent2="accent2" accent3="accent3" accent4="accent4" accent5="accent5" accent6="accent6" hlink="hlink" folHlink="folHlink"/>
   <p:sldLayoutIdLst>
-    <p:sldLayoutId xmlns:r="http://schemas.openxmlformats.org/officeDocument/2006/relationships" id="2147483649" r:id="R0029bbf00650425b"/>
+    <p:sldLayoutId xmlns:r="http://schemas.openxmlformats.org/officeDocument/2006/relationships" id="2147483649" r:id="Ra6aa8b6f67ed4d6f"/>
   </p:sldLayoutIdLst>
   <p:txStyles>
     <p:titleStyle>
@@ -1484,14 +1484,14 @@
       </p:grpSpPr>
       <p:pic>
         <p:nvPicPr>
-          <p:cNvPr id="9" name=""/>
+          <p:cNvPr id="10" name=""/>
           <p:cNvPicPr>
             <a:picLocks xmlns:a="http://schemas.openxmlformats.org/drawingml/2006/main" noChangeAspect="1"/>
           </p:cNvPicPr>
           <p:nvPr/>
         </p:nvPicPr>
         <p:blipFill>
-          <a:blip xmlns:r="http://schemas.openxmlformats.org/officeDocument/2006/relationships" xmlns:a="http://schemas.openxmlformats.org/drawingml/2006/main" r:embed="R125758be4a0148f1"/>
+          <a:blip xmlns:r="http://schemas.openxmlformats.org/officeDocument/2006/relationships" xmlns:a="http://schemas.openxmlformats.org/drawingml/2006/main" r:embed="R417d066a62874d85"/>
           <a:srcRect xmlns:a="http://schemas.openxmlformats.org/drawingml/2006/main" l="0" t="27" r="0" b="27"/>
           <a:stretch xmlns:a="http://schemas.openxmlformats.org/drawingml/2006/main">
             <a:fillRect l="0" t="0" r="0" b="0"/>
@@ -1573,6 +1573,7 @@
           <a:lstStyle xmlns:a="http://schemas.openxmlformats.org/drawingml/2006/main"/>
           <a:p xmlns:a="http://schemas.openxmlformats.org/drawingml/2006/main">
             <a:pPr algn="l">
+              <a:buNone/>
               <a:defRPr sz="1125" b="1">
                 <a:solidFill>
                   <a:srgbClr val="F5B942"/>
@@ -1623,6 +1624,7 @@
           <a:lstStyle xmlns:a="http://schemas.openxmlformats.org/drawingml/2006/main"/>
           <a:p xmlns:a="http://schemas.openxmlformats.org/drawingml/2006/main">
             <a:pPr algn="l">
+              <a:buNone/>
               <a:defRPr sz="3900" b="1">
                 <a:solidFill>
                   <a:srgbClr val="FFFFFF"/>
@@ -1640,6 +1642,7 @@
           </a:p>
           <a:p xmlns:a="http://schemas.openxmlformats.org/drawingml/2006/main">
             <a:pPr algn="l">
+              <a:buNone/>
               <a:defRPr sz="3900" b="1">
                 <a:solidFill>
                   <a:srgbClr val="FFFFFF"/>
@@ -1690,6 +1693,7 @@
           <a:lstStyle xmlns:a="http://schemas.openxmlformats.org/drawingml/2006/main"/>
           <a:p xmlns:a="http://schemas.openxmlformats.org/drawingml/2006/main">
             <a:pPr algn="l">
+              <a:buNone/>
               <a:defRPr sz="1725" b="0">
                 <a:solidFill>
                   <a:srgbClr val="DDE8E8"/>
@@ -1702,7 +1706,7 @@
                   <a:srgbClr val="DDE8E8"/>
                 </a:solidFill>
               </a:rPr>
-              <a:t>Reka pembantu AI yang sempit, boleh diuji dan kekal di bawah kawalan manusia.</a:t>
+              <a:t>Reka pembantu AI yang fokus, boleh diuji dan sentiasa di bawah kawalan manusia.</a:t>
             </a:r>
           </a:p>
         </p:txBody>
@@ -1771,6 +1775,7 @@
           <a:lstStyle xmlns:a="http://schemas.openxmlformats.org/drawingml/2006/main"/>
           <a:p xmlns:a="http://schemas.openxmlformats.org/drawingml/2006/main">
             <a:pPr algn="l">
+              <a:buNone/>
               <a:defRPr sz="1350" b="1">
                 <a:solidFill>
                   <a:srgbClr val="F5B942"/>
@@ -1821,6 +1826,7 @@
           <a:lstStyle xmlns:a="http://schemas.openxmlformats.org/drawingml/2006/main"/>
           <a:p xmlns:a="http://schemas.openxmlformats.org/drawingml/2006/main">
             <a:pPr algn="l">
+              <a:buNone/>
               <a:defRPr sz="1275" b="0">
                 <a:solidFill>
                   <a:srgbClr val="FFFFFF"/>
@@ -1900,6 +1906,7 @@
           <a:lstStyle xmlns:a="http://schemas.openxmlformats.org/drawingml/2006/main"/>
           <a:p xmlns:a="http://schemas.openxmlformats.org/drawingml/2006/main">
             <a:pPr algn="l">
+              <a:buNone/>
               <a:defRPr sz="1050" b="1">
                 <a:solidFill>
                   <a:srgbClr val="008A8A"/>
@@ -1950,6 +1957,7 @@
           <a:lstStyle xmlns:a="http://schemas.openxmlformats.org/drawingml/2006/main"/>
           <a:p xmlns:a="http://schemas.openxmlformats.org/drawingml/2006/main">
             <a:pPr algn="r">
+              <a:buNone/>
               <a:defRPr sz="1050" b="1">
                 <a:solidFill>
                   <a:srgbClr val="60707A"/>
@@ -2031,6 +2039,7 @@
           <a:lstStyle xmlns:a="http://schemas.openxmlformats.org/drawingml/2006/main"/>
           <a:p xmlns:a="http://schemas.openxmlformats.org/drawingml/2006/main">
             <a:pPr algn="l">
+              <a:buNone/>
               <a:defRPr sz="3000" b="1">
                 <a:solidFill>
                   <a:srgbClr val="102F48"/>
@@ -2182,6 +2191,7 @@
           <a:lstStyle xmlns:a="http://schemas.openxmlformats.org/drawingml/2006/main"/>
           <a:p xmlns:a="http://schemas.openxmlformats.org/drawingml/2006/main">
             <a:pPr algn="l">
+              <a:buNone/>
               <a:defRPr sz="1125" b="1">
                 <a:solidFill>
                   <a:srgbClr val="008A8A"/>
@@ -2232,6 +2242,7 @@
           <a:lstStyle xmlns:a="http://schemas.openxmlformats.org/drawingml/2006/main"/>
           <a:p xmlns:a="http://schemas.openxmlformats.org/drawingml/2006/main">
             <a:pPr algn="l">
+              <a:buNone/>
               <a:defRPr sz="2250" b="1">
                 <a:solidFill>
                   <a:srgbClr val="102F48"/>
@@ -2249,6 +2260,7 @@
           </a:p>
           <a:p xmlns:a="http://schemas.openxmlformats.org/drawingml/2006/main">
             <a:pPr algn="l">
+              <a:buNone/>
               <a:defRPr sz="2250" b="1">
                 <a:solidFill>
                   <a:srgbClr val="102F48"/>
@@ -2299,6 +2311,7 @@
           <a:lstStyle xmlns:a="http://schemas.openxmlformats.org/drawingml/2006/main"/>
           <a:p xmlns:a="http://schemas.openxmlformats.org/drawingml/2006/main">
             <a:pPr algn="l">
+              <a:buNone/>
               <a:defRPr sz="1425" b="0">
                 <a:solidFill>
                   <a:srgbClr val="60707A"/>
@@ -2349,6 +2362,7 @@
           <a:lstStyle xmlns:a="http://schemas.openxmlformats.org/drawingml/2006/main"/>
           <a:p xmlns:a="http://schemas.openxmlformats.org/drawingml/2006/main">
             <a:pPr algn="ctr">
+              <a:buNone/>
               <a:defRPr sz="1275" b="1">
                 <a:solidFill>
                   <a:srgbClr val="102F48"/>
@@ -2366,6 +2380,7 @@
           </a:p>
           <a:p xmlns:a="http://schemas.openxmlformats.org/drawingml/2006/main">
             <a:pPr algn="ctr">
+              <a:buNone/>
               <a:defRPr sz="1275" b="1">
                 <a:solidFill>
                   <a:srgbClr val="102F48"/>
@@ -2416,6 +2431,7 @@
           <a:lstStyle xmlns:a="http://schemas.openxmlformats.org/drawingml/2006/main"/>
           <a:p xmlns:a="http://schemas.openxmlformats.org/drawingml/2006/main">
             <a:pPr algn="l">
+              <a:buNone/>
               <a:defRPr sz="1125" b="1">
                 <a:solidFill>
                   <a:srgbClr val="F5B942"/>
@@ -2466,6 +2482,7 @@
           <a:lstStyle xmlns:a="http://schemas.openxmlformats.org/drawingml/2006/main"/>
           <a:p xmlns:a="http://schemas.openxmlformats.org/drawingml/2006/main">
             <a:pPr algn="l">
+              <a:buNone/>
               <a:defRPr sz="2250" b="1">
                 <a:solidFill>
                   <a:srgbClr val="FFFFFF"/>
@@ -2483,6 +2500,7 @@
           </a:p>
           <a:p xmlns:a="http://schemas.openxmlformats.org/drawingml/2006/main">
             <a:pPr algn="l">
+              <a:buNone/>
               <a:defRPr sz="2250" b="1">
                 <a:solidFill>
                   <a:srgbClr val="FFFFFF"/>
@@ -2533,6 +2551,7 @@
           <a:lstStyle xmlns:a="http://schemas.openxmlformats.org/drawingml/2006/main"/>
           <a:p xmlns:a="http://schemas.openxmlformats.org/drawingml/2006/main">
             <a:pPr algn="l">
+              <a:buNone/>
               <a:defRPr sz="1425" b="0">
                 <a:solidFill>
                   <a:srgbClr val="DDE8E8"/>
@@ -2583,6 +2602,7 @@
           <a:lstStyle xmlns:a="http://schemas.openxmlformats.org/drawingml/2006/main"/>
           <a:p xmlns:a="http://schemas.openxmlformats.org/drawingml/2006/main">
             <a:pPr algn="ctr">
+              <a:buNone/>
               <a:defRPr sz="1500" b="1">
                 <a:solidFill>
                   <a:srgbClr val="008A8A"/>
@@ -2662,6 +2682,7 @@
           <a:lstStyle xmlns:a="http://schemas.openxmlformats.org/drawingml/2006/main"/>
           <a:p xmlns:a="http://schemas.openxmlformats.org/drawingml/2006/main">
             <a:pPr algn="l">
+              <a:buNone/>
               <a:defRPr sz="1050" b="1">
                 <a:solidFill>
                   <a:srgbClr val="008A8A"/>
@@ -2712,6 +2733,7 @@
           <a:lstStyle xmlns:a="http://schemas.openxmlformats.org/drawingml/2006/main"/>
           <a:p xmlns:a="http://schemas.openxmlformats.org/drawingml/2006/main">
             <a:pPr algn="r">
+              <a:buNone/>
               <a:defRPr sz="1050" b="1">
                 <a:solidFill>
                   <a:srgbClr val="60707A"/>
@@ -2793,6 +2815,7 @@
           <a:lstStyle xmlns:a="http://schemas.openxmlformats.org/drawingml/2006/main"/>
           <a:p xmlns:a="http://schemas.openxmlformats.org/drawingml/2006/main">
             <a:pPr algn="l">
+              <a:buNone/>
               <a:defRPr sz="3000" b="1">
                 <a:solidFill>
                   <a:srgbClr val="102F48"/>
@@ -2878,6 +2901,7 @@
           <a:lstStyle xmlns:a="http://schemas.openxmlformats.org/drawingml/2006/main"/>
           <a:p xmlns:a="http://schemas.openxmlformats.org/drawingml/2006/main">
             <a:pPr algn="l">
+              <a:buNone/>
               <a:defRPr sz="1125" b="1">
                 <a:solidFill>
                   <a:srgbClr val="008A8A"/>
@@ -2928,6 +2952,7 @@
           <a:lstStyle xmlns:a="http://schemas.openxmlformats.org/drawingml/2006/main"/>
           <a:p xmlns:a="http://schemas.openxmlformats.org/drawingml/2006/main">
             <a:pPr algn="l">
+              <a:buNone/>
               <a:defRPr sz="1125" b="1">
                 <a:solidFill>
                   <a:srgbClr val="008A8A"/>
@@ -2978,6 +3003,7 @@
           <a:lstStyle xmlns:a="http://schemas.openxmlformats.org/drawingml/2006/main"/>
           <a:p xmlns:a="http://schemas.openxmlformats.org/drawingml/2006/main">
             <a:pPr algn="l">
+              <a:buNone/>
               <a:defRPr sz="1725" b="1">
                 <a:solidFill>
                   <a:srgbClr val="17212B"/>
@@ -3063,6 +3089,7 @@
           <a:lstStyle xmlns:a="http://schemas.openxmlformats.org/drawingml/2006/main"/>
           <a:p xmlns:a="http://schemas.openxmlformats.org/drawingml/2006/main">
             <a:pPr algn="l">
+              <a:buNone/>
               <a:defRPr sz="1125" b="1">
                 <a:solidFill>
                   <a:srgbClr val="102F48"/>
@@ -3113,6 +3140,7 @@
           <a:lstStyle xmlns:a="http://schemas.openxmlformats.org/drawingml/2006/main"/>
           <a:p xmlns:a="http://schemas.openxmlformats.org/drawingml/2006/main">
             <a:pPr algn="l">
+              <a:buNone/>
               <a:defRPr sz="1125" b="1">
                 <a:solidFill>
                   <a:srgbClr val="008A8A"/>
@@ -3163,6 +3191,7 @@
           <a:lstStyle xmlns:a="http://schemas.openxmlformats.org/drawingml/2006/main"/>
           <a:p xmlns:a="http://schemas.openxmlformats.org/drawingml/2006/main">
             <a:pPr algn="l">
+              <a:buNone/>
               <a:defRPr sz="1725" b="1">
                 <a:solidFill>
                   <a:srgbClr val="17212B"/>
@@ -3248,6 +3277,7 @@
           <a:lstStyle xmlns:a="http://schemas.openxmlformats.org/drawingml/2006/main"/>
           <a:p xmlns:a="http://schemas.openxmlformats.org/drawingml/2006/main">
             <a:pPr algn="l">
+              <a:buNone/>
               <a:defRPr sz="1125" b="1">
                 <a:solidFill>
                   <a:srgbClr val="102F48"/>
@@ -3298,6 +3328,7 @@
           <a:lstStyle xmlns:a="http://schemas.openxmlformats.org/drawingml/2006/main"/>
           <a:p xmlns:a="http://schemas.openxmlformats.org/drawingml/2006/main">
             <a:pPr algn="l">
+              <a:buNone/>
               <a:defRPr sz="1125" b="1">
                 <a:solidFill>
                   <a:srgbClr val="008A8A"/>
@@ -3348,6 +3379,7 @@
           <a:lstStyle xmlns:a="http://schemas.openxmlformats.org/drawingml/2006/main"/>
           <a:p xmlns:a="http://schemas.openxmlformats.org/drawingml/2006/main">
             <a:pPr algn="l">
+              <a:buNone/>
               <a:defRPr sz="1725" b="1">
                 <a:solidFill>
                   <a:srgbClr val="17212B"/>
@@ -3433,6 +3465,7 @@
           <a:lstStyle xmlns:a="http://schemas.openxmlformats.org/drawingml/2006/main"/>
           <a:p xmlns:a="http://schemas.openxmlformats.org/drawingml/2006/main">
             <a:pPr algn="l">
+              <a:buNone/>
               <a:defRPr sz="1125" b="1">
                 <a:solidFill>
                   <a:srgbClr val="F5B942"/>
@@ -3483,6 +3516,7 @@
           <a:lstStyle xmlns:a="http://schemas.openxmlformats.org/drawingml/2006/main"/>
           <a:p xmlns:a="http://schemas.openxmlformats.org/drawingml/2006/main">
             <a:pPr algn="l">
+              <a:buNone/>
               <a:defRPr sz="1125" b="1">
                 <a:solidFill>
                   <a:srgbClr val="F5B942"/>
@@ -3533,6 +3567,7 @@
           <a:lstStyle xmlns:a="http://schemas.openxmlformats.org/drawingml/2006/main"/>
           <a:p xmlns:a="http://schemas.openxmlformats.org/drawingml/2006/main">
             <a:pPr algn="l">
+              <a:buNone/>
               <a:defRPr sz="1725" b="1">
                 <a:solidFill>
                   <a:srgbClr val="FFFFFF"/>
@@ -3583,6 +3618,7 @@
           <a:lstStyle xmlns:a="http://schemas.openxmlformats.org/drawingml/2006/main"/>
           <a:p xmlns:a="http://schemas.openxmlformats.org/drawingml/2006/main">
             <a:pPr algn="ctr">
+              <a:buNone/>
               <a:defRPr sz="1500" b="1">
                 <a:solidFill>
                   <a:srgbClr val="008A8A"/>
@@ -3662,6 +3698,7 @@
           <a:lstStyle xmlns:a="http://schemas.openxmlformats.org/drawingml/2006/main"/>
           <a:p xmlns:a="http://schemas.openxmlformats.org/drawingml/2006/main">
             <a:pPr algn="l">
+              <a:buNone/>
               <a:defRPr sz="1050" b="1">
                 <a:solidFill>
                   <a:srgbClr val="008A8A"/>
@@ -3712,6 +3749,7 @@
           <a:lstStyle xmlns:a="http://schemas.openxmlformats.org/drawingml/2006/main"/>
           <a:p xmlns:a="http://schemas.openxmlformats.org/drawingml/2006/main">
             <a:pPr algn="r">
+              <a:buNone/>
               <a:defRPr sz="1050" b="1">
                 <a:solidFill>
                   <a:srgbClr val="60707A"/>
@@ -3793,6 +3831,7 @@
           <a:lstStyle xmlns:a="http://schemas.openxmlformats.org/drawingml/2006/main"/>
           <a:p xmlns:a="http://schemas.openxmlformats.org/drawingml/2006/main">
             <a:pPr algn="l">
+              <a:buNone/>
               <a:defRPr sz="3000" b="1">
                 <a:solidFill>
                   <a:srgbClr val="102F48"/>
@@ -4033,6 +4072,7 @@
           <a:lstStyle xmlns:a="http://schemas.openxmlformats.org/drawingml/2006/main"/>
           <a:p xmlns:a="http://schemas.openxmlformats.org/drawingml/2006/main">
             <a:pPr algn="l">
+              <a:buNone/>
               <a:defRPr sz="1050" b="1">
                 <a:solidFill>
                   <a:srgbClr val="008A8A"/>
@@ -4083,6 +4123,7 @@
           <a:lstStyle xmlns:a="http://schemas.openxmlformats.org/drawingml/2006/main"/>
           <a:p xmlns:a="http://schemas.openxmlformats.org/drawingml/2006/main">
             <a:pPr algn="ctr">
+              <a:buNone/>
               <a:defRPr sz="1500" b="1">
                 <a:solidFill>
                   <a:srgbClr val="102F48"/>
@@ -4168,6 +4209,7 @@
           <a:lstStyle xmlns:a="http://schemas.openxmlformats.org/drawingml/2006/main"/>
           <a:p xmlns:a="http://schemas.openxmlformats.org/drawingml/2006/main">
             <a:pPr algn="l">
+              <a:buNone/>
               <a:defRPr sz="1050" b="1">
                 <a:solidFill>
                   <a:srgbClr val="008A8A"/>
@@ -4218,6 +4260,7 @@
           <a:lstStyle xmlns:a="http://schemas.openxmlformats.org/drawingml/2006/main"/>
           <a:p xmlns:a="http://schemas.openxmlformats.org/drawingml/2006/main">
             <a:pPr algn="ctr">
+              <a:buNone/>
               <a:defRPr sz="1500" b="1">
                 <a:solidFill>
                   <a:srgbClr val="102F48"/>
@@ -4303,6 +4346,7 @@
           <a:lstStyle xmlns:a="http://schemas.openxmlformats.org/drawingml/2006/main"/>
           <a:p xmlns:a="http://schemas.openxmlformats.org/drawingml/2006/main">
             <a:pPr algn="l">
+              <a:buNone/>
               <a:defRPr sz="1050" b="1">
                 <a:solidFill>
                   <a:srgbClr val="008A8A"/>
@@ -4353,6 +4397,7 @@
           <a:lstStyle xmlns:a="http://schemas.openxmlformats.org/drawingml/2006/main"/>
           <a:p xmlns:a="http://schemas.openxmlformats.org/drawingml/2006/main">
             <a:pPr algn="ctr">
+              <a:buNone/>
               <a:defRPr sz="1500" b="1">
                 <a:solidFill>
                   <a:srgbClr val="102F48"/>
@@ -4438,6 +4483,7 @@
           <a:lstStyle xmlns:a="http://schemas.openxmlformats.org/drawingml/2006/main"/>
           <a:p xmlns:a="http://schemas.openxmlformats.org/drawingml/2006/main">
             <a:pPr algn="l">
+              <a:buNone/>
               <a:defRPr sz="1050" b="1">
                 <a:solidFill>
                   <a:srgbClr val="008A8A"/>
@@ -4488,6 +4534,7 @@
           <a:lstStyle xmlns:a="http://schemas.openxmlformats.org/drawingml/2006/main"/>
           <a:p xmlns:a="http://schemas.openxmlformats.org/drawingml/2006/main">
             <a:pPr algn="ctr">
+              <a:buNone/>
               <a:defRPr sz="1500" b="1">
                 <a:solidFill>
                   <a:srgbClr val="102F48"/>
@@ -4573,6 +4620,7 @@
           <a:lstStyle xmlns:a="http://schemas.openxmlformats.org/drawingml/2006/main"/>
           <a:p xmlns:a="http://schemas.openxmlformats.org/drawingml/2006/main">
             <a:pPr algn="l">
+              <a:buNone/>
               <a:defRPr sz="1050" b="1">
                 <a:solidFill>
                   <a:srgbClr val="008A8A"/>
@@ -4623,6 +4671,7 @@
           <a:lstStyle xmlns:a="http://schemas.openxmlformats.org/drawingml/2006/main"/>
           <a:p xmlns:a="http://schemas.openxmlformats.org/drawingml/2006/main">
             <a:pPr algn="ctr">
+              <a:buNone/>
               <a:defRPr sz="1500" b="1">
                 <a:solidFill>
                   <a:srgbClr val="102F48"/>
@@ -4708,6 +4757,7 @@
           <a:lstStyle xmlns:a="http://schemas.openxmlformats.org/drawingml/2006/main"/>
           <a:p xmlns:a="http://schemas.openxmlformats.org/drawingml/2006/main">
             <a:pPr algn="l">
+              <a:buNone/>
               <a:defRPr sz="1050" b="1">
                 <a:solidFill>
                   <a:srgbClr val="F5B942"/>
@@ -4758,6 +4808,7 @@
           <a:lstStyle xmlns:a="http://schemas.openxmlformats.org/drawingml/2006/main"/>
           <a:p xmlns:a="http://schemas.openxmlformats.org/drawingml/2006/main">
             <a:pPr algn="ctr">
+              <a:buNone/>
               <a:defRPr sz="1500" b="1">
                 <a:solidFill>
                   <a:srgbClr val="FFFFFF"/>
@@ -4841,6 +4892,7 @@
           <a:lstStyle xmlns:a="http://schemas.openxmlformats.org/drawingml/2006/main"/>
           <a:p xmlns:a="http://schemas.openxmlformats.org/drawingml/2006/main">
             <a:pPr algn="ctr">
+              <a:buNone/>
               <a:defRPr sz="1575" b="1">
                 <a:solidFill>
                   <a:srgbClr val="FFFFFF"/>
@@ -4920,6 +4972,7 @@
           <a:lstStyle xmlns:a="http://schemas.openxmlformats.org/drawingml/2006/main"/>
           <a:p xmlns:a="http://schemas.openxmlformats.org/drawingml/2006/main">
             <a:pPr algn="l">
+              <a:buNone/>
               <a:defRPr sz="1050" b="1">
                 <a:solidFill>
                   <a:srgbClr val="008A8A"/>
@@ -4970,6 +5023,7 @@
           <a:lstStyle xmlns:a="http://schemas.openxmlformats.org/drawingml/2006/main"/>
           <a:p xmlns:a="http://schemas.openxmlformats.org/drawingml/2006/main">
             <a:pPr algn="r">
+              <a:buNone/>
               <a:defRPr sz="1050" b="1">
                 <a:solidFill>
                   <a:srgbClr val="60707A"/>
@@ -5051,6 +5105,7 @@
           <a:lstStyle xmlns:a="http://schemas.openxmlformats.org/drawingml/2006/main"/>
           <a:p xmlns:a="http://schemas.openxmlformats.org/drawingml/2006/main">
             <a:pPr algn="l">
+              <a:buNone/>
               <a:defRPr sz="3000" b="1">
                 <a:solidFill>
                   <a:srgbClr val="102F48"/>
@@ -5256,6 +5311,7 @@
           <a:lstStyle xmlns:a="http://schemas.openxmlformats.org/drawingml/2006/main"/>
           <a:p xmlns:a="http://schemas.openxmlformats.org/drawingml/2006/main">
             <a:pPr algn="ctr">
+              <a:buNone/>
               <a:defRPr sz="1875" b="1">
                 <a:solidFill>
                   <a:srgbClr val="FFFFFF"/>
@@ -5306,6 +5362,7 @@
           <a:lstStyle xmlns:a="http://schemas.openxmlformats.org/drawingml/2006/main"/>
           <a:p xmlns:a="http://schemas.openxmlformats.org/drawingml/2006/main">
             <a:pPr algn="ctr">
+              <a:buNone/>
               <a:defRPr sz="1425" b="0">
                 <a:solidFill>
                   <a:srgbClr val="FFFFFF"/>
@@ -5323,6 +5380,7 @@
           </a:p>
           <a:p xmlns:a="http://schemas.openxmlformats.org/drawingml/2006/main">
             <a:pPr algn="ctr">
+              <a:buNone/>
               <a:defRPr sz="1425" b="0">
                 <a:solidFill>
                   <a:srgbClr val="FFFFFF"/>
@@ -5340,6 +5398,7 @@
           </a:p>
           <a:p xmlns:a="http://schemas.openxmlformats.org/drawingml/2006/main">
             <a:pPr algn="ctr">
+              <a:buNone/>
               <a:defRPr sz="1425" b="0">
                 <a:solidFill>
                   <a:srgbClr val="FFFFFF"/>
@@ -5390,6 +5449,7 @@
           <a:lstStyle xmlns:a="http://schemas.openxmlformats.org/drawingml/2006/main"/>
           <a:p xmlns:a="http://schemas.openxmlformats.org/drawingml/2006/main">
             <a:pPr algn="ctr">
+              <a:buNone/>
               <a:defRPr sz="1875" b="1">
                 <a:solidFill>
                   <a:srgbClr val="102F48"/>
@@ -5440,6 +5500,7 @@
           <a:lstStyle xmlns:a="http://schemas.openxmlformats.org/drawingml/2006/main"/>
           <a:p xmlns:a="http://schemas.openxmlformats.org/drawingml/2006/main">
             <a:pPr algn="ctr">
+              <a:buNone/>
               <a:defRPr sz="1425" b="0">
                 <a:solidFill>
                   <a:srgbClr val="102F48"/>
@@ -5457,6 +5518,7 @@
           </a:p>
           <a:p xmlns:a="http://schemas.openxmlformats.org/drawingml/2006/main">
             <a:pPr algn="ctr">
+              <a:buNone/>
               <a:defRPr sz="1425" b="0">
                 <a:solidFill>
                   <a:srgbClr val="102F48"/>
@@ -5474,6 +5536,7 @@
           </a:p>
           <a:p xmlns:a="http://schemas.openxmlformats.org/drawingml/2006/main">
             <a:pPr algn="ctr">
+              <a:buNone/>
               <a:defRPr sz="1425" b="0">
                 <a:solidFill>
                   <a:srgbClr val="102F48"/>
@@ -5524,6 +5587,7 @@
           <a:lstStyle xmlns:a="http://schemas.openxmlformats.org/drawingml/2006/main"/>
           <a:p xmlns:a="http://schemas.openxmlformats.org/drawingml/2006/main">
             <a:pPr algn="ctr">
+              <a:buNone/>
               <a:defRPr sz="1875" b="1">
                 <a:solidFill>
                   <a:srgbClr val="FFFFFF"/>
@@ -5574,6 +5638,7 @@
           <a:lstStyle xmlns:a="http://schemas.openxmlformats.org/drawingml/2006/main"/>
           <a:p xmlns:a="http://schemas.openxmlformats.org/drawingml/2006/main">
             <a:pPr algn="ctr">
+              <a:buNone/>
               <a:defRPr sz="1425" b="0">
                 <a:solidFill>
                   <a:srgbClr val="FFFFFF"/>
@@ -5591,6 +5656,7 @@
           </a:p>
           <a:p xmlns:a="http://schemas.openxmlformats.org/drawingml/2006/main">
             <a:pPr algn="ctr">
+              <a:buNone/>
               <a:defRPr sz="1425" b="0">
                 <a:solidFill>
                   <a:srgbClr val="FFFFFF"/>
@@ -5608,6 +5674,7 @@
           </a:p>
           <a:p xmlns:a="http://schemas.openxmlformats.org/drawingml/2006/main">
             <a:pPr algn="ctr">
+              <a:buNone/>
               <a:defRPr sz="1425" b="0">
                 <a:solidFill>
                   <a:srgbClr val="FFFFFF"/>
@@ -5658,6 +5725,7 @@
           <a:lstStyle xmlns:a="http://schemas.openxmlformats.org/drawingml/2006/main"/>
           <a:p xmlns:a="http://schemas.openxmlformats.org/drawingml/2006/main">
             <a:pPr algn="ctr">
+              <a:buNone/>
               <a:defRPr sz="1575" b="1">
                 <a:solidFill>
                   <a:srgbClr val="008A8A"/>
@@ -5737,6 +5805,7 @@
           <a:lstStyle xmlns:a="http://schemas.openxmlformats.org/drawingml/2006/main"/>
           <a:p xmlns:a="http://schemas.openxmlformats.org/drawingml/2006/main">
             <a:pPr algn="l">
+              <a:buNone/>
               <a:defRPr sz="1050" b="1">
                 <a:solidFill>
                   <a:srgbClr val="F5B942"/>
@@ -5787,6 +5856,7 @@
           <a:lstStyle xmlns:a="http://schemas.openxmlformats.org/drawingml/2006/main"/>
           <a:p xmlns:a="http://schemas.openxmlformats.org/drawingml/2006/main">
             <a:pPr algn="l">
+              <a:buNone/>
               <a:defRPr sz="3150" b="1">
                 <a:solidFill>
                   <a:srgbClr val="FFFFFF"/>
@@ -5804,6 +5874,7 @@
           </a:p>
           <a:p xmlns:a="http://schemas.openxmlformats.org/drawingml/2006/main">
             <a:pPr algn="l">
+              <a:buNone/>
               <a:defRPr sz="3150" b="1">
                 <a:solidFill>
                   <a:srgbClr val="FFFFFF"/>
@@ -5955,6 +6026,7 @@
           <a:lstStyle xmlns:a="http://schemas.openxmlformats.org/drawingml/2006/main"/>
           <a:p xmlns:a="http://schemas.openxmlformats.org/drawingml/2006/main">
             <a:pPr algn="ctr">
+              <a:buNone/>
               <a:defRPr sz="1200" b="1">
                 <a:solidFill>
                   <a:srgbClr val="102F48"/>
@@ -5972,6 +6044,7 @@
           </a:p>
           <a:p xmlns:a="http://schemas.openxmlformats.org/drawingml/2006/main">
             <a:pPr algn="ctr">
+              <a:buNone/>
               <a:defRPr sz="1200" b="1">
                 <a:solidFill>
                   <a:srgbClr val="102F48"/>
@@ -6053,6 +6126,7 @@
           <a:lstStyle xmlns:a="http://schemas.openxmlformats.org/drawingml/2006/main"/>
           <a:p xmlns:a="http://schemas.openxmlformats.org/drawingml/2006/main">
             <a:pPr algn="l">
+              <a:buNone/>
               <a:defRPr sz="1425" b="1">
                 <a:solidFill>
                   <a:srgbClr val="FFFFFF"/>
@@ -6103,6 +6177,7 @@
           <a:lstStyle xmlns:a="http://schemas.openxmlformats.org/drawingml/2006/main"/>
           <a:p xmlns:a="http://schemas.openxmlformats.org/drawingml/2006/main">
             <a:pPr algn="l">
+              <a:buNone/>
               <a:defRPr sz="1275" b="0">
                 <a:solidFill>
                   <a:srgbClr val="DDE8E8"/>
@@ -6184,6 +6259,7 @@
           <a:lstStyle xmlns:a="http://schemas.openxmlformats.org/drawingml/2006/main"/>
           <a:p xmlns:a="http://schemas.openxmlformats.org/drawingml/2006/main">
             <a:pPr algn="l">
+              <a:buNone/>
               <a:defRPr sz="1425" b="1">
                 <a:solidFill>
                   <a:srgbClr val="FFFFFF"/>
@@ -6234,6 +6310,7 @@
           <a:lstStyle xmlns:a="http://schemas.openxmlformats.org/drawingml/2006/main"/>
           <a:p xmlns:a="http://schemas.openxmlformats.org/drawingml/2006/main">
             <a:pPr algn="l">
+              <a:buNone/>
               <a:defRPr sz="1275" b="0">
                 <a:solidFill>
                   <a:srgbClr val="DDE8E8"/>
@@ -6315,6 +6392,7 @@
           <a:lstStyle xmlns:a="http://schemas.openxmlformats.org/drawingml/2006/main"/>
           <a:p xmlns:a="http://schemas.openxmlformats.org/drawingml/2006/main">
             <a:pPr algn="l">
+              <a:buNone/>
               <a:defRPr sz="1425" b="1">
                 <a:solidFill>
                   <a:srgbClr val="FFFFFF"/>
@@ -6365,6 +6443,7 @@
           <a:lstStyle xmlns:a="http://schemas.openxmlformats.org/drawingml/2006/main"/>
           <a:p xmlns:a="http://schemas.openxmlformats.org/drawingml/2006/main">
             <a:pPr algn="l">
+              <a:buNone/>
               <a:defRPr sz="1275" b="0">
                 <a:solidFill>
                   <a:srgbClr val="DDE8E8"/>
@@ -6446,6 +6525,7 @@
           <a:lstStyle xmlns:a="http://schemas.openxmlformats.org/drawingml/2006/main"/>
           <a:p xmlns:a="http://schemas.openxmlformats.org/drawingml/2006/main">
             <a:pPr algn="l">
+              <a:buNone/>
               <a:defRPr sz="1425" b="1">
                 <a:solidFill>
                   <a:srgbClr val="FFFFFF"/>
@@ -6496,6 +6576,7 @@
           <a:lstStyle xmlns:a="http://schemas.openxmlformats.org/drawingml/2006/main"/>
           <a:p xmlns:a="http://schemas.openxmlformats.org/drawingml/2006/main">
             <a:pPr algn="l">
+              <a:buNone/>
               <a:defRPr sz="1275" b="0">
                 <a:solidFill>
                   <a:srgbClr val="DDE8E8"/>
@@ -6546,6 +6627,7 @@
           <a:lstStyle xmlns:a="http://schemas.openxmlformats.org/drawingml/2006/main"/>
           <a:p xmlns:a="http://schemas.openxmlformats.org/drawingml/2006/main">
             <a:pPr algn="ctr">
+              <a:buNone/>
               <a:defRPr sz="1500" b="1">
                 <a:solidFill>
                   <a:srgbClr val="F5B942"/>

</xml_diff>